<commit_message>
presentation: fixes and polish
</commit_message>
<xml_diff>
--- a/presentation/Built-to-Pet_Pitch-Präsentation_V1.0.pptx
+++ b/presentation/Built-to-Pet_Pitch-Präsentation_V1.0.pptx
@@ -110,6 +110,67 @@
     </p:ext>
   </p:extLst>
 </p:presentation>
+</file>
+
+<file path=ppt/revisionInfo.xml><?xml version="1.0" encoding="utf-8"?>
+<p1510:revInfo xmlns:a="http://schemas.openxmlformats.org/drawingml/2006/main" xmlns:r="http://schemas.openxmlformats.org/officeDocument/2006/relationships" xmlns:p1510="http://schemas.microsoft.com/office/powerpoint/2015/10/main">
+  <p1510:revLst>
+    <p1510:client id="{63611392-ABA7-4C69-BB10-505288B64293}" v="1" dt="2026-08-23T09:46:11.011"/>
+  </p1510:revLst>
+</p1510:revInfo>
+</file>
+
+<file path=ppt/changesInfos/changesInfo1.xml><?xml version="1.0" encoding="utf-8"?>
+<pc:chgInfo xmlns:a="http://schemas.openxmlformats.org/drawingml/2006/main" xmlns:r="http://schemas.openxmlformats.org/officeDocument/2006/relationships" xmlns:ac="http://schemas.microsoft.com/office/drawing/2013/main/command" xmlns:pc="http://schemas.microsoft.com/office/powerpoint/2013/main/command">
+  <pc:docChgLst>
+    <pc:chgData name="Natalie Schumacher" userId="71de4cbf455843de" providerId="LiveId" clId="{AB3F2223-419F-4DFC-ACA3-F45510E015B6}"/>
+    <pc:docChg chg="undo custSel modSld">
+      <pc:chgData name="Natalie Schumacher" userId="71de4cbf455843de" providerId="LiveId" clId="{AB3F2223-419F-4DFC-ACA3-F45510E015B6}" dt="2026-08-23T09:47:02.544" v="141" actId="20577"/>
+      <pc:docMkLst>
+        <pc:docMk/>
+      </pc:docMkLst>
+      <pc:sldChg chg="modSp mod">
+        <pc:chgData name="Natalie Schumacher" userId="71de4cbf455843de" providerId="LiveId" clId="{AB3F2223-419F-4DFC-ACA3-F45510E015B6}" dt="2026-08-23T09:47:02.544" v="141" actId="20577"/>
+        <pc:sldMkLst>
+          <pc:docMk/>
+          <pc:sldMk cId="0" sldId="256"/>
+        </pc:sldMkLst>
+        <pc:spChg chg="mod">
+          <ac:chgData name="Natalie Schumacher" userId="71de4cbf455843de" providerId="LiveId" clId="{AB3F2223-419F-4DFC-ACA3-F45510E015B6}" dt="2026-08-23T09:46:09.489" v="2" actId="21"/>
+          <ac:spMkLst>
+            <pc:docMk/>
+            <pc:sldMk cId="0" sldId="256"/>
+            <ac:spMk id="11" creationId="{00000000-0000-0000-0000-000000000000}"/>
+          </ac:spMkLst>
+        </pc:spChg>
+        <pc:spChg chg="mod">
+          <ac:chgData name="Natalie Schumacher" userId="71de4cbf455843de" providerId="LiveId" clId="{AB3F2223-419F-4DFC-ACA3-F45510E015B6}" dt="2026-08-23T09:47:02.544" v="141" actId="20577"/>
+          <ac:spMkLst>
+            <pc:docMk/>
+            <pc:sldMk cId="0" sldId="256"/>
+            <ac:spMk id="15" creationId="{00000000-0000-0000-0000-000000000000}"/>
+          </ac:spMkLst>
+        </pc:spChg>
+        <pc:spChg chg="mod">
+          <ac:chgData name="Natalie Schumacher" userId="71de4cbf455843de" providerId="LiveId" clId="{AB3F2223-419F-4DFC-ACA3-F45510E015B6}" dt="2026-08-23T09:46:12.486" v="5" actId="20577"/>
+          <ac:spMkLst>
+            <pc:docMk/>
+            <pc:sldMk cId="0" sldId="256"/>
+            <ac:spMk id="16" creationId="{00000000-0000-0000-0000-000000000000}"/>
+          </ac:spMkLst>
+        </pc:spChg>
+        <pc:spChg chg="mod">
+          <ac:chgData name="Natalie Schumacher" userId="71de4cbf455843de" providerId="LiveId" clId="{AB3F2223-419F-4DFC-ACA3-F45510E015B6}" dt="2026-08-23T09:46:38.320" v="115" actId="20577"/>
+          <ac:spMkLst>
+            <pc:docMk/>
+            <pc:sldMk cId="0" sldId="256"/>
+            <ac:spMk id="21" creationId="{00000000-0000-0000-0000-000000000000}"/>
+          </ac:spMkLst>
+        </pc:spChg>
+      </pc:sldChg>
+    </pc:docChg>
+  </pc:docChgLst>
+</pc:chgInfo>
 </file>
 
 <file path=ppt/notesMasters/notesMaster1.xml><?xml version="1.0" encoding="utf-8"?>
@@ -1044,187 +1105,6 @@
               <a:t> LAN-Party</a:t>
             </a:r>
           </a:p>
-          <a:p>
-            <a:pPr marL="152400" indent="-152400">
-              <a:lnSpc>
-                <a:spcPct val="115000"/>
-              </a:lnSpc>
-              <a:spcAft>
-                <a:spcPts val="800"/>
-              </a:spcAft>
-              <a:buSzPct val="100000"/>
-              <a:buChar char="•"/>
-            </a:pPr>
-            <a:r>
-              <a:rPr lang="en-US" sz="1600" dirty="0" err="1">
-                <a:solidFill>
-                  <a:srgbClr val="1E2B15"/>
-                </a:solidFill>
-                <a:latin typeface="Aptos" panose="020B0004020202020204" pitchFamily="34" charset="0"/>
-                <a:ea typeface="NoBulliesAllowed" panose="02000603000000000000" pitchFamily="2" charset="0"/>
-                <a:cs typeface="Calibri" pitchFamily="34" charset="-120"/>
-              </a:rPr>
-              <a:t>Wird</a:t>
-            </a:r>
-            <a:r>
-              <a:rPr lang="en-US" sz="1600" dirty="0">
-                <a:solidFill>
-                  <a:srgbClr val="1E2B15"/>
-                </a:solidFill>
-                <a:latin typeface="Aptos" panose="020B0004020202020204" pitchFamily="34" charset="0"/>
-                <a:ea typeface="NoBulliesAllowed" panose="02000603000000000000" pitchFamily="2" charset="0"/>
-                <a:cs typeface="Calibri" pitchFamily="34" charset="-120"/>
-              </a:rPr>
-              <a:t> </a:t>
-            </a:r>
-            <a:r>
-              <a:rPr lang="en-US" sz="1600" dirty="0" err="1">
-                <a:solidFill>
-                  <a:srgbClr val="1E2B15"/>
-                </a:solidFill>
-                <a:latin typeface="Aptos" panose="020B0004020202020204" pitchFamily="34" charset="0"/>
-                <a:ea typeface="NoBulliesAllowed" panose="02000603000000000000" pitchFamily="2" charset="0"/>
-                <a:cs typeface="Calibri" pitchFamily="34" charset="-120"/>
-              </a:rPr>
-              <a:t>passiv</a:t>
-            </a:r>
-            <a:r>
-              <a:rPr lang="en-US" sz="1600" dirty="0">
-                <a:solidFill>
-                  <a:srgbClr val="1E2B15"/>
-                </a:solidFill>
-                <a:latin typeface="Aptos" panose="020B0004020202020204" pitchFamily="34" charset="0"/>
-                <a:ea typeface="NoBulliesAllowed" panose="02000603000000000000" pitchFamily="2" charset="0"/>
-                <a:cs typeface="Calibri" pitchFamily="34" charset="-120"/>
-              </a:rPr>
-              <a:t> </a:t>
-            </a:r>
-            <a:r>
-              <a:rPr lang="en-US" sz="1600" dirty="0" err="1">
-                <a:solidFill>
-                  <a:srgbClr val="1E2B15"/>
-                </a:solidFill>
-                <a:latin typeface="Aptos" panose="020B0004020202020204" pitchFamily="34" charset="0"/>
-                <a:ea typeface="NoBulliesAllowed" panose="02000603000000000000" pitchFamily="2" charset="0"/>
-                <a:cs typeface="Calibri" pitchFamily="34" charset="-120"/>
-              </a:rPr>
-              <a:t>trainiert</a:t>
-            </a:r>
-            <a:r>
-              <a:rPr lang="en-US" sz="1600" dirty="0">
-                <a:solidFill>
-                  <a:srgbClr val="1E2B15"/>
-                </a:solidFill>
-                <a:latin typeface="Aptos" panose="020B0004020202020204" pitchFamily="34" charset="0"/>
-                <a:ea typeface="NoBulliesAllowed" panose="02000603000000000000" pitchFamily="2" charset="0"/>
-                <a:cs typeface="Calibri" pitchFamily="34" charset="-120"/>
-              </a:rPr>
-              <a:t>, </a:t>
-            </a:r>
-            <a:r>
-              <a:rPr lang="en-US" sz="1600" dirty="0" err="1">
-                <a:solidFill>
-                  <a:srgbClr val="1E2B15"/>
-                </a:solidFill>
-                <a:latin typeface="Aptos" panose="020B0004020202020204" pitchFamily="34" charset="0"/>
-                <a:ea typeface="NoBulliesAllowed" panose="02000603000000000000" pitchFamily="2" charset="0"/>
-                <a:cs typeface="Calibri" pitchFamily="34" charset="-120"/>
-              </a:rPr>
-              <a:t>während</a:t>
-            </a:r>
-            <a:r>
-              <a:rPr lang="en-US" sz="1600" dirty="0">
-                <a:solidFill>
-                  <a:srgbClr val="1E2B15"/>
-                </a:solidFill>
-                <a:latin typeface="Aptos" panose="020B0004020202020204" pitchFamily="34" charset="0"/>
-                <a:ea typeface="NoBulliesAllowed" panose="02000603000000000000" pitchFamily="2" charset="0"/>
-                <a:cs typeface="Calibri" pitchFamily="34" charset="-120"/>
-              </a:rPr>
-              <a:t> </a:t>
-            </a:r>
-            <a:r>
-              <a:rPr lang="en-US" sz="1600" dirty="0" err="1">
-                <a:solidFill>
-                  <a:srgbClr val="1E2B15"/>
-                </a:solidFill>
-                <a:latin typeface="Aptos" panose="020B0004020202020204" pitchFamily="34" charset="0"/>
-                <a:ea typeface="NoBulliesAllowed" panose="02000603000000000000" pitchFamily="2" charset="0"/>
-                <a:cs typeface="Calibri" pitchFamily="34" charset="-120"/>
-              </a:rPr>
-              <a:t>andere</a:t>
-            </a:r>
-            <a:r>
-              <a:rPr lang="en-US" sz="1600" dirty="0">
-                <a:solidFill>
-                  <a:srgbClr val="1E2B15"/>
-                </a:solidFill>
-                <a:latin typeface="Aptos" panose="020B0004020202020204" pitchFamily="34" charset="0"/>
-                <a:ea typeface="NoBulliesAllowed" panose="02000603000000000000" pitchFamily="2" charset="0"/>
-                <a:cs typeface="Calibri" pitchFamily="34" charset="-120"/>
-              </a:rPr>
-              <a:t> </a:t>
-            </a:r>
-            <a:r>
-              <a:rPr lang="en-US" sz="1600" dirty="0" err="1">
-                <a:solidFill>
-                  <a:srgbClr val="1E2B15"/>
-                </a:solidFill>
-                <a:latin typeface="Aptos" panose="020B0004020202020204" pitchFamily="34" charset="0"/>
-                <a:ea typeface="NoBulliesAllowed" panose="02000603000000000000" pitchFamily="2" charset="0"/>
-                <a:cs typeface="Calibri" pitchFamily="34" charset="-120"/>
-              </a:rPr>
-              <a:t>Spiele</a:t>
-            </a:r>
-            <a:r>
-              <a:rPr lang="en-US" sz="1600" dirty="0">
-                <a:solidFill>
-                  <a:srgbClr val="1E2B15"/>
-                </a:solidFill>
-                <a:latin typeface="Aptos" panose="020B0004020202020204" pitchFamily="34" charset="0"/>
-                <a:ea typeface="NoBulliesAllowed" panose="02000603000000000000" pitchFamily="2" charset="0"/>
-                <a:cs typeface="Calibri" pitchFamily="34" charset="-120"/>
-              </a:rPr>
-              <a:t> </a:t>
-            </a:r>
-            <a:r>
-              <a:rPr lang="en-US" sz="1600" dirty="0" err="1">
-                <a:solidFill>
-                  <a:srgbClr val="1E2B15"/>
-                </a:solidFill>
-                <a:latin typeface="Aptos" panose="020B0004020202020204" pitchFamily="34" charset="0"/>
-                <a:ea typeface="NoBulliesAllowed" panose="02000603000000000000" pitchFamily="2" charset="0"/>
-                <a:cs typeface="Calibri" pitchFamily="34" charset="-120"/>
-              </a:rPr>
-              <a:t>gespielt</a:t>
-            </a:r>
-            <a:r>
-              <a:rPr lang="en-US" sz="1600" dirty="0">
-                <a:solidFill>
-                  <a:srgbClr val="1E2B15"/>
-                </a:solidFill>
-                <a:latin typeface="Aptos" panose="020B0004020202020204" pitchFamily="34" charset="0"/>
-                <a:ea typeface="NoBulliesAllowed" panose="02000603000000000000" pitchFamily="2" charset="0"/>
-                <a:cs typeface="Calibri" pitchFamily="34" charset="-120"/>
-              </a:rPr>
-              <a:t> </a:t>
-            </a:r>
-            <a:r>
-              <a:rPr lang="en-US" sz="1600" dirty="0" err="1">
-                <a:solidFill>
-                  <a:srgbClr val="1E2B15"/>
-                </a:solidFill>
-                <a:latin typeface="Aptos" panose="020B0004020202020204" pitchFamily="34" charset="0"/>
-                <a:ea typeface="NoBulliesAllowed" panose="02000603000000000000" pitchFamily="2" charset="0"/>
-                <a:cs typeface="Calibri" pitchFamily="34" charset="-120"/>
-              </a:rPr>
-              <a:t>werden</a:t>
-            </a:r>
-            <a:endParaRPr lang="en-US" sz="1600" dirty="0">
-              <a:latin typeface="Aptos" panose="020B0004020202020204" pitchFamily="34" charset="0"/>
-              <a:ea typeface="NoBulliesAllowed" panose="02000603000000000000" pitchFamily="2" charset="0"/>
-            </a:endParaRPr>
-          </a:p>
         </p:txBody>
       </p:sp>
       <p:sp>
@@ -1347,7 +1227,18 @@
                 <a:ea typeface="Cambria" pitchFamily="34" charset="-122"/>
                 <a:cs typeface="Cambria" pitchFamily="34" charset="-120"/>
               </a:rPr>
-              <a:t>What We Built</a:t>
+              <a:t>Unser </a:t>
+            </a:r>
+            <a:r>
+              <a:rPr lang="en-US" sz="2800" b="1" dirty="0" err="1">
+                <a:solidFill>
+                  <a:srgbClr val="2C5F2D"/>
+                </a:solidFill>
+                <a:latin typeface="Frankfurt" panose="000B0000000000000000" pitchFamily="34" charset="0"/>
+                <a:ea typeface="Cambria" pitchFamily="34" charset="-122"/>
+                <a:cs typeface="Cambria" pitchFamily="34" charset="-120"/>
+              </a:rPr>
+              <a:t>Ergebnis</a:t>
             </a:r>
             <a:endParaRPr lang="en-US" sz="2800" dirty="0">
               <a:latin typeface="Frankfurt" panose="000B0000000000000000" pitchFamily="34" charset="0"/>
@@ -1472,55 +1363,169 @@
             </a:pPr>
             <a:r>
               <a:rPr lang="en-US" sz="1600" dirty="0" err="1">
-                <a:latin typeface="Aptos" panose="020B0004020202020204" pitchFamily="34" charset="0"/>
-                <a:ea typeface="NoBulliesAllowed" panose="02000603000000000000" pitchFamily="2" charset="0"/>
-              </a:rPr>
-              <a:t>Änderungen</a:t>
+                <a:solidFill>
+                  <a:srgbClr val="1E2B15"/>
+                </a:solidFill>
+                <a:latin typeface="Aptos" panose="020B0004020202020204" pitchFamily="34" charset="0"/>
+                <a:ea typeface="NoBulliesAllowed" panose="02000603000000000000" pitchFamily="2" charset="0"/>
+                <a:cs typeface="Calibri" pitchFamily="34" charset="-120"/>
+              </a:rPr>
+              <a:t>Wird</a:t>
             </a:r>
             <a:r>
               <a:rPr lang="en-US" sz="1600" dirty="0">
-                <a:latin typeface="Aptos" panose="020B0004020202020204" pitchFamily="34" charset="0"/>
-                <a:ea typeface="NoBulliesAllowed" panose="02000603000000000000" pitchFamily="2" charset="0"/>
+                <a:solidFill>
+                  <a:srgbClr val="1E2B15"/>
+                </a:solidFill>
+                <a:latin typeface="Aptos" panose="020B0004020202020204" pitchFamily="34" charset="0"/>
+                <a:ea typeface="NoBulliesAllowed" panose="02000603000000000000" pitchFamily="2" charset="0"/>
+                <a:cs typeface="Calibri" pitchFamily="34" charset="-120"/>
               </a:rPr>
               <a:t> </a:t>
             </a:r>
             <a:r>
               <a:rPr lang="en-US" sz="1600" dirty="0" err="1">
-                <a:latin typeface="Aptos" panose="020B0004020202020204" pitchFamily="34" charset="0"/>
-                <a:ea typeface="NoBulliesAllowed" panose="02000603000000000000" pitchFamily="2" charset="0"/>
+                <a:solidFill>
+                  <a:srgbClr val="1E2B15"/>
+                </a:solidFill>
+                <a:latin typeface="Aptos" panose="020B0004020202020204" pitchFamily="34" charset="0"/>
+                <a:ea typeface="NoBulliesAllowed" panose="02000603000000000000" pitchFamily="2" charset="0"/>
+                <a:cs typeface="Calibri" pitchFamily="34" charset="-120"/>
+              </a:rPr>
+              <a:t>passiv</a:t>
+            </a:r>
+            <a:r>
+              <a:rPr lang="en-US" sz="1600" dirty="0">
+                <a:solidFill>
+                  <a:srgbClr val="1E2B15"/>
+                </a:solidFill>
+                <a:latin typeface="Aptos" panose="020B0004020202020204" pitchFamily="34" charset="0"/>
+                <a:ea typeface="NoBulliesAllowed" panose="02000603000000000000" pitchFamily="2" charset="0"/>
+                <a:cs typeface="Calibri" pitchFamily="34" charset="-120"/>
+              </a:rPr>
+              <a:t> </a:t>
+            </a:r>
+            <a:r>
+              <a:rPr lang="en-US" sz="1600" dirty="0" err="1">
+                <a:solidFill>
+                  <a:srgbClr val="1E2B15"/>
+                </a:solidFill>
+                <a:latin typeface="Aptos" panose="020B0004020202020204" pitchFamily="34" charset="0"/>
+                <a:ea typeface="NoBulliesAllowed" panose="02000603000000000000" pitchFamily="2" charset="0"/>
+                <a:cs typeface="Calibri" pitchFamily="34" charset="-120"/>
+              </a:rPr>
+              <a:t>trainiert</a:t>
+            </a:r>
+            <a:r>
+              <a:rPr lang="en-US" sz="1600" dirty="0">
+                <a:solidFill>
+                  <a:srgbClr val="1E2B15"/>
+                </a:solidFill>
+                <a:latin typeface="Aptos" panose="020B0004020202020204" pitchFamily="34" charset="0"/>
+                <a:ea typeface="NoBulliesAllowed" panose="02000603000000000000" pitchFamily="2" charset="0"/>
+                <a:cs typeface="Calibri" pitchFamily="34" charset="-120"/>
+              </a:rPr>
+              <a:t>, </a:t>
+            </a:r>
+            <a:r>
+              <a:rPr lang="en-US" sz="1600" dirty="0" err="1">
+                <a:solidFill>
+                  <a:srgbClr val="1E2B15"/>
+                </a:solidFill>
+                <a:latin typeface="Aptos" panose="020B0004020202020204" pitchFamily="34" charset="0"/>
+                <a:ea typeface="NoBulliesAllowed" panose="02000603000000000000" pitchFamily="2" charset="0"/>
+                <a:cs typeface="Calibri" pitchFamily="34" charset="-120"/>
+              </a:rPr>
+              <a:t>während</a:t>
+            </a:r>
+            <a:r>
+              <a:rPr lang="en-US" sz="1600" dirty="0">
+                <a:solidFill>
+                  <a:srgbClr val="1E2B15"/>
+                </a:solidFill>
+                <a:latin typeface="Aptos" panose="020B0004020202020204" pitchFamily="34" charset="0"/>
+                <a:ea typeface="NoBulliesAllowed" panose="02000603000000000000" pitchFamily="2" charset="0"/>
+                <a:cs typeface="Calibri" pitchFamily="34" charset="-120"/>
+              </a:rPr>
+              <a:t> </a:t>
+            </a:r>
+            <a:r>
+              <a:rPr lang="en-US" sz="1600" dirty="0" err="1">
+                <a:solidFill>
+                  <a:srgbClr val="1E2B15"/>
+                </a:solidFill>
+                <a:latin typeface="Aptos" panose="020B0004020202020204" pitchFamily="34" charset="0"/>
+                <a:ea typeface="NoBulliesAllowed" panose="02000603000000000000" pitchFamily="2" charset="0"/>
+                <a:cs typeface="Calibri" pitchFamily="34" charset="-120"/>
+              </a:rPr>
+              <a:t>andere</a:t>
+            </a:r>
+            <a:r>
+              <a:rPr lang="en-US" sz="1600" dirty="0">
+                <a:solidFill>
+                  <a:srgbClr val="1E2B15"/>
+                </a:solidFill>
+                <a:latin typeface="Aptos" panose="020B0004020202020204" pitchFamily="34" charset="0"/>
+                <a:ea typeface="NoBulliesAllowed" panose="02000603000000000000" pitchFamily="2" charset="0"/>
+                <a:cs typeface="Calibri" pitchFamily="34" charset="-120"/>
+              </a:rPr>
+              <a:t> </a:t>
+            </a:r>
+            <a:r>
+              <a:rPr lang="en-US" sz="1600" dirty="0" err="1">
+                <a:solidFill>
+                  <a:srgbClr val="1E2B15"/>
+                </a:solidFill>
+                <a:latin typeface="Aptos" panose="020B0004020202020204" pitchFamily="34" charset="0"/>
+                <a:ea typeface="NoBulliesAllowed" panose="02000603000000000000" pitchFamily="2" charset="0"/>
+                <a:cs typeface="Calibri" pitchFamily="34" charset="-120"/>
+              </a:rPr>
+              <a:t>Spiele</a:t>
+            </a:r>
+            <a:r>
+              <a:rPr lang="en-US" sz="1600" dirty="0">
+                <a:solidFill>
+                  <a:srgbClr val="1E2B15"/>
+                </a:solidFill>
+                <a:latin typeface="Aptos" panose="020B0004020202020204" pitchFamily="34" charset="0"/>
+                <a:ea typeface="NoBulliesAllowed" panose="02000603000000000000" pitchFamily="2" charset="0"/>
+                <a:cs typeface="Calibri" pitchFamily="34" charset="-120"/>
+              </a:rPr>
+              <a:t> </a:t>
+            </a:r>
+            <a:r>
+              <a:rPr lang="en-US" sz="1600" dirty="0" err="1">
+                <a:solidFill>
+                  <a:srgbClr val="1E2B15"/>
+                </a:solidFill>
+                <a:latin typeface="Aptos" panose="020B0004020202020204" pitchFamily="34" charset="0"/>
+                <a:ea typeface="NoBulliesAllowed" panose="02000603000000000000" pitchFamily="2" charset="0"/>
+                <a:cs typeface="Calibri" pitchFamily="34" charset="-120"/>
+              </a:rPr>
+              <a:t>gespielt</a:t>
+            </a:r>
+            <a:r>
+              <a:rPr lang="en-US" sz="1600" dirty="0">
+                <a:solidFill>
+                  <a:srgbClr val="1E2B15"/>
+                </a:solidFill>
+                <a:latin typeface="Aptos" panose="020B0004020202020204" pitchFamily="34" charset="0"/>
+                <a:ea typeface="NoBulliesAllowed" panose="02000603000000000000" pitchFamily="2" charset="0"/>
+                <a:cs typeface="Calibri" pitchFamily="34" charset="-120"/>
+              </a:rPr>
+              <a:t> </a:t>
+            </a:r>
+            <a:r>
+              <a:rPr lang="en-US" sz="1600" dirty="0" err="1">
+                <a:solidFill>
+                  <a:srgbClr val="1E2B15"/>
+                </a:solidFill>
+                <a:latin typeface="Aptos" panose="020B0004020202020204" pitchFamily="34" charset="0"/>
+                <a:ea typeface="NoBulliesAllowed" panose="02000603000000000000" pitchFamily="2" charset="0"/>
+                <a:cs typeface="Calibri" pitchFamily="34" charset="-120"/>
               </a:rPr>
               <a:t>werden</a:t>
             </a:r>
-            <a:r>
-              <a:rPr lang="en-US" sz="1600" dirty="0">
-                <a:latin typeface="Aptos" panose="020B0004020202020204" pitchFamily="34" charset="0"/>
-                <a:ea typeface="NoBulliesAllowed" panose="02000603000000000000" pitchFamily="2" charset="0"/>
-              </a:rPr>
-              <a:t> </a:t>
-            </a:r>
-            <a:r>
-              <a:rPr lang="en-US" sz="1600" dirty="0" err="1">
-                <a:latin typeface="Aptos" panose="020B0004020202020204" pitchFamily="34" charset="0"/>
-                <a:ea typeface="NoBulliesAllowed" panose="02000603000000000000" pitchFamily="2" charset="0"/>
-              </a:rPr>
-              <a:t>persistiert</a:t>
-            </a:r>
-            <a:endParaRPr lang="en-US" sz="1600" dirty="0">
-              <a:latin typeface="Aptos" panose="020B0004020202020204" pitchFamily="34" charset="0"/>
-              <a:ea typeface="NoBulliesAllowed" panose="02000603000000000000" pitchFamily="2" charset="0"/>
-            </a:endParaRPr>
-          </a:p>
-          <a:p>
-            <a:pPr marL="152400" indent="-152400">
-              <a:lnSpc>
-                <a:spcPct val="115000"/>
-              </a:lnSpc>
-              <a:spcAft>
-                <a:spcPts val="800"/>
-              </a:spcAft>
-              <a:buSzPct val="100000"/>
-              <a:buChar char="•"/>
-            </a:pPr>
             <a:endParaRPr lang="en-US" sz="1600" dirty="0">
               <a:latin typeface="Aptos" panose="020B0004020202020204" pitchFamily="34" charset="0"/>
               <a:ea typeface="NoBulliesAllowed" panose="02000603000000000000" pitchFamily="2" charset="0"/>
@@ -1834,7 +1839,7 @@
                 <a:ea typeface="NoBulliesAllowed" panose="02000603000000000000" pitchFamily="2" charset="0"/>
                 <a:cs typeface="Calibri" pitchFamily="34" charset="-120"/>
               </a:rPr>
-              <a:t>Kümmert</a:t>
+              <a:t>Gegenseitiges</a:t>
             </a:r>
             <a:r>
               <a:rPr lang="en-US" sz="1600" dirty="0">
@@ -1845,18 +1850,18 @@
                 <a:ea typeface="NoBulliesAllowed" panose="02000603000000000000" pitchFamily="2" charset="0"/>
                 <a:cs typeface="Calibri" pitchFamily="34" charset="-120"/>
               </a:rPr>
-              <a:t> </a:t>
-            </a:r>
-            <a:r>
-              <a:rPr lang="en-US" sz="1600" dirty="0" err="1">
-                <a:solidFill>
-                  <a:srgbClr val="1E2B15"/>
-                </a:solidFill>
-                <a:latin typeface="Aptos" panose="020B0004020202020204" pitchFamily="34" charset="0"/>
-                <a:ea typeface="NoBulliesAllowed" panose="02000603000000000000" pitchFamily="2" charset="0"/>
-                <a:cs typeface="Calibri" pitchFamily="34" charset="-120"/>
-              </a:rPr>
-              <a:t>euch</a:t>
+              <a:t> “</a:t>
+            </a:r>
+            <a:r>
+              <a:rPr lang="en-US" sz="1600" dirty="0" err="1">
+                <a:solidFill>
+                  <a:srgbClr val="1E2B15"/>
+                </a:solidFill>
+                <a:latin typeface="Aptos" panose="020B0004020202020204" pitchFamily="34" charset="0"/>
+                <a:ea typeface="NoBulliesAllowed" panose="02000603000000000000" pitchFamily="2" charset="0"/>
+                <a:cs typeface="Calibri" pitchFamily="34" charset="-120"/>
+              </a:rPr>
+              <a:t>Haustier</a:t>
             </a:r>
             <a:r>
               <a:rPr lang="en-US" sz="1600" dirty="0">
@@ -1867,62 +1872,18 @@
                 <a:ea typeface="NoBulliesAllowed" panose="02000603000000000000" pitchFamily="2" charset="0"/>
                 <a:cs typeface="Calibri" pitchFamily="34" charset="-120"/>
               </a:rPr>
-              <a:t> </a:t>
-            </a:r>
-            <a:r>
-              <a:rPr lang="en-US" sz="1600" dirty="0" err="1">
-                <a:solidFill>
-                  <a:srgbClr val="1E2B15"/>
-                </a:solidFill>
-                <a:latin typeface="Aptos" panose="020B0004020202020204" pitchFamily="34" charset="0"/>
-                <a:ea typeface="NoBulliesAllowed" panose="02000603000000000000" pitchFamily="2" charset="0"/>
-                <a:cs typeface="Calibri" pitchFamily="34" charset="-120"/>
-              </a:rPr>
-              <a:t>gegenseitig</a:t>
-            </a:r>
-            <a:r>
-              <a:rPr lang="en-US" sz="1600" dirty="0">
-                <a:solidFill>
-                  <a:srgbClr val="1E2B15"/>
-                </a:solidFill>
-                <a:latin typeface="Aptos" panose="020B0004020202020204" pitchFamily="34" charset="0"/>
-                <a:ea typeface="NoBulliesAllowed" panose="02000603000000000000" pitchFamily="2" charset="0"/>
-                <a:cs typeface="Calibri" pitchFamily="34" charset="-120"/>
-              </a:rPr>
-              <a:t> um </a:t>
-            </a:r>
-            <a:r>
-              <a:rPr lang="en-US" sz="1600" dirty="0" err="1">
-                <a:solidFill>
-                  <a:srgbClr val="1E2B15"/>
-                </a:solidFill>
-                <a:latin typeface="Aptos" panose="020B0004020202020204" pitchFamily="34" charset="0"/>
-                <a:ea typeface="NoBulliesAllowed" panose="02000603000000000000" pitchFamily="2" charset="0"/>
-                <a:cs typeface="Calibri" pitchFamily="34" charset="-120"/>
-              </a:rPr>
-              <a:t>eure</a:t>
-            </a:r>
-            <a:r>
-              <a:rPr lang="en-US" sz="1600" dirty="0">
-                <a:solidFill>
-                  <a:srgbClr val="1E2B15"/>
-                </a:solidFill>
-                <a:latin typeface="Aptos" panose="020B0004020202020204" pitchFamily="34" charset="0"/>
-                <a:ea typeface="NoBulliesAllowed" panose="02000603000000000000" pitchFamily="2" charset="0"/>
-                <a:cs typeface="Calibri" pitchFamily="34" charset="-120"/>
-              </a:rPr>
-              <a:t> </a:t>
-            </a:r>
-            <a:r>
-              <a:rPr lang="en-US" sz="1600" dirty="0" err="1">
-                <a:solidFill>
-                  <a:srgbClr val="1E2B15"/>
-                </a:solidFill>
-                <a:latin typeface="Aptos" panose="020B0004020202020204" pitchFamily="34" charset="0"/>
-                <a:ea typeface="NoBulliesAllowed" panose="02000603000000000000" pitchFamily="2" charset="0"/>
-                <a:cs typeface="Calibri" pitchFamily="34" charset="-120"/>
-              </a:rPr>
-              <a:t>Haustiere</a:t>
+              <a:t>”-</a:t>
+            </a:r>
+            <a:r>
+              <a:rPr lang="en-US" sz="1600" dirty="0" err="1">
+                <a:solidFill>
+                  <a:srgbClr val="1E2B15"/>
+                </a:solidFill>
+                <a:latin typeface="Aptos" panose="020B0004020202020204" pitchFamily="34" charset="0"/>
+                <a:ea typeface="NoBulliesAllowed" panose="02000603000000000000" pitchFamily="2" charset="0"/>
+                <a:cs typeface="Calibri" pitchFamily="34" charset="-120"/>
+              </a:rPr>
+              <a:t>hüten</a:t>
             </a:r>
             <a:endParaRPr lang="en-US" sz="1600" dirty="0">
               <a:solidFill>
@@ -1953,7 +1914,7 @@
                 <a:ea typeface="NoBulliesAllowed" panose="02000603000000000000" pitchFamily="2" charset="0"/>
                 <a:cs typeface="Calibri" pitchFamily="34" charset="-120"/>
               </a:rPr>
-              <a:t>Überrascht</a:t>
+              <a:t>Überraschungsangriffe</a:t>
             </a:r>
             <a:r>
               <a:rPr lang="en-US" sz="1600" dirty="0">
@@ -1964,96 +1925,27 @@
                 <a:ea typeface="NoBulliesAllowed" panose="02000603000000000000" pitchFamily="2" charset="0"/>
                 <a:cs typeface="Calibri" pitchFamily="34" charset="-120"/>
               </a:rPr>
-              <a:t> </a:t>
-            </a:r>
-            <a:r>
-              <a:rPr lang="en-US" sz="1600" dirty="0" err="1">
-                <a:solidFill>
-                  <a:srgbClr val="1E2B15"/>
-                </a:solidFill>
-                <a:latin typeface="Aptos" panose="020B0004020202020204" pitchFamily="34" charset="0"/>
-                <a:ea typeface="NoBulliesAllowed" panose="02000603000000000000" pitchFamily="2" charset="0"/>
-                <a:cs typeface="Calibri" pitchFamily="34" charset="-120"/>
-              </a:rPr>
-              <a:t>euch</a:t>
-            </a:r>
-            <a:r>
-              <a:rPr lang="en-US" sz="1600" dirty="0">
-                <a:solidFill>
-                  <a:srgbClr val="1E2B15"/>
-                </a:solidFill>
-                <a:latin typeface="Aptos" panose="020B0004020202020204" pitchFamily="34" charset="0"/>
-                <a:ea typeface="NoBulliesAllowed" panose="02000603000000000000" pitchFamily="2" charset="0"/>
-                <a:cs typeface="Calibri" pitchFamily="34" charset="-120"/>
-              </a:rPr>
-              <a:t> </a:t>
-            </a:r>
-            <a:r>
-              <a:rPr lang="en-US" sz="1600" dirty="0" err="1">
-                <a:solidFill>
-                  <a:srgbClr val="1E2B15"/>
-                </a:solidFill>
-                <a:latin typeface="Aptos" panose="020B0004020202020204" pitchFamily="34" charset="0"/>
-                <a:ea typeface="NoBulliesAllowed" panose="02000603000000000000" pitchFamily="2" charset="0"/>
-                <a:cs typeface="Calibri" pitchFamily="34" charset="-120"/>
-              </a:rPr>
-              <a:t>mit</a:t>
-            </a:r>
-            <a:r>
-              <a:rPr lang="en-US" sz="1600" dirty="0">
-                <a:solidFill>
-                  <a:srgbClr val="1E2B15"/>
-                </a:solidFill>
-                <a:latin typeface="Aptos" panose="020B0004020202020204" pitchFamily="34" charset="0"/>
-                <a:ea typeface="NoBulliesAllowed" panose="02000603000000000000" pitchFamily="2" charset="0"/>
-                <a:cs typeface="Calibri" pitchFamily="34" charset="-120"/>
-              </a:rPr>
-              <a:t> </a:t>
-            </a:r>
-            <a:r>
-              <a:rPr lang="en-US" sz="1600" dirty="0" err="1">
-                <a:solidFill>
-                  <a:srgbClr val="1E2B15"/>
-                </a:solidFill>
-                <a:latin typeface="Aptos" panose="020B0004020202020204" pitchFamily="34" charset="0"/>
-                <a:ea typeface="NoBulliesAllowed" panose="02000603000000000000" pitchFamily="2" charset="0"/>
-                <a:cs typeface="Calibri" pitchFamily="34" charset="-120"/>
-              </a:rPr>
-              <a:t>plötzlichen</a:t>
-            </a:r>
-            <a:r>
-              <a:rPr lang="en-US" sz="1600" dirty="0">
-                <a:solidFill>
-                  <a:srgbClr val="1E2B15"/>
-                </a:solidFill>
-                <a:latin typeface="Aptos" panose="020B0004020202020204" pitchFamily="34" charset="0"/>
-                <a:ea typeface="NoBulliesAllowed" panose="02000603000000000000" pitchFamily="2" charset="0"/>
-                <a:cs typeface="Calibri" pitchFamily="34" charset="-120"/>
-              </a:rPr>
-              <a:t> </a:t>
-            </a:r>
-            <a:r>
-              <a:rPr lang="en-US" sz="1600" dirty="0" err="1">
-                <a:solidFill>
-                  <a:srgbClr val="1E2B15"/>
-                </a:solidFill>
-                <a:latin typeface="Aptos" panose="020B0004020202020204" pitchFamily="34" charset="0"/>
-                <a:ea typeface="NoBulliesAllowed" panose="02000603000000000000" pitchFamily="2" charset="0"/>
-                <a:cs typeface="Calibri" pitchFamily="34" charset="-120"/>
-              </a:rPr>
-              <a:t>Angriffen</a:t>
-            </a:r>
-            <a:r>
-              <a:rPr lang="en-US" sz="1600" dirty="0">
-                <a:solidFill>
-                  <a:srgbClr val="1E2B15"/>
-                </a:solidFill>
-                <a:latin typeface="Aptos" panose="020B0004020202020204" pitchFamily="34" charset="0"/>
-                <a:ea typeface="NoBulliesAllowed" panose="02000603000000000000" pitchFamily="2" charset="0"/>
-                <a:cs typeface="Calibri" pitchFamily="34" charset="-120"/>
-              </a:rPr>
-              <a:t>.</a:t>
-            </a:r>
+              <a:t> für </a:t>
+            </a:r>
+            <a:r>
+              <a:rPr lang="en-US" sz="1600" dirty="0" err="1">
+                <a:solidFill>
+                  <a:srgbClr val="1E2B15"/>
+                </a:solidFill>
+                <a:latin typeface="Aptos" panose="020B0004020202020204" pitchFamily="34" charset="0"/>
+                <a:ea typeface="NoBulliesAllowed" panose="02000603000000000000" pitchFamily="2" charset="0"/>
+                <a:cs typeface="Calibri" pitchFamily="34" charset="-120"/>
+              </a:rPr>
+              <a:t>Statusboosts</a:t>
+            </a:r>
+            <a:endParaRPr lang="en-US" sz="1600" dirty="0">
+              <a:solidFill>
+                <a:srgbClr val="1E2B15"/>
+              </a:solidFill>
+              <a:latin typeface="Aptos" panose="020B0004020202020204" pitchFamily="34" charset="0"/>
+              <a:ea typeface="NoBulliesAllowed" panose="02000603000000000000" pitchFamily="2" charset="0"/>
+              <a:cs typeface="Calibri" pitchFamily="34" charset="-120"/>
+            </a:endParaRPr>
           </a:p>
         </p:txBody>
       </p:sp>

</xml_diff>